<commit_message>
Publish final portfolio links and readable slides
</commit_message>
<xml_diff>
--- a/output/pptx/AI-Harness-Portfolio-2026-v11.pptx
+++ b/output/pptx/AI-Harness-Portfolio-2026-v11.pptx
@@ -1931,8 +1931,8 @@
       </p:pic>
       <p:pic>
         <p:nvPicPr>
-          <p:cNvPr id="3" name="Image 1" descr="https://github.com/dtype2100/orca-orchestrate-engineering">
-            <a:hlinkClick r:id="rId3" tooltip="https://github.com/dtype2100/orca-orchestrate-engineering"/>
+          <p:cNvPr id="3" name="Image 1" descr="https://github.com/dtype2100/work-handoff">
+            <a:hlinkClick r:id="rId3" tooltip="https://github.com/dtype2100/work-handoff"/>
           </p:cNvPr>
           <p:cNvPicPr>
             <a:picLocks noChangeAspect="1"/>
@@ -1941,6 +1941,58 @@
         </p:nvPicPr>
         <p:blipFill>
           <a:blip r:embed="rId2"/>
+          <a:stretch>
+            <a:fillRect/>
+          </a:stretch>
+        </p:blipFill>
+        <p:spPr>
+          <a:xfrm>
+            <a:off x="7910603" y="3254135"/>
+            <a:ext cx="2381672" cy="231196"/>
+          </a:xfrm>
+          <a:prstGeom prst="rect">
+            <a:avLst/>
+          </a:prstGeom>
+        </p:spPr>
+      </p:pic>
+      <p:pic>
+        <p:nvPicPr>
+          <p:cNvPr id="4" name="Image 2" descr="https://github.com/dtype2100/ai-evidence-review">
+            <a:hlinkClick r:id="rId5" tooltip="https://github.com/dtype2100/ai-evidence-review"/>
+          </p:cNvPr>
+          <p:cNvPicPr>
+            <a:picLocks noChangeAspect="1"/>
+          </p:cNvPicPr>
+          <p:nvPr/>
+        </p:nvPicPr>
+        <p:blipFill>
+          <a:blip r:embed="rId4"/>
+          <a:stretch>
+            <a:fillRect/>
+          </a:stretch>
+        </p:blipFill>
+        <p:spPr>
+          <a:xfrm>
+            <a:off x="7910603" y="4151602"/>
+            <a:ext cx="2799351" cy="231196"/>
+          </a:xfrm>
+          <a:prstGeom prst="rect">
+            <a:avLst/>
+          </a:prstGeom>
+        </p:spPr>
+      </p:pic>
+      <p:pic>
+        <p:nvPicPr>
+          <p:cNvPr id="5" name="Image 3" descr="https://github.com/dtype2100/orca-orchestrate-engineering">
+            <a:hlinkClick r:id="rId7" tooltip="https://github.com/dtype2100/orca-orchestrate-engineering"/>
+          </p:cNvPr>
+          <p:cNvPicPr>
+            <a:picLocks noChangeAspect="1"/>
+          </p:cNvPicPr>
+          <p:nvPr/>
+        </p:nvPicPr>
+        <p:blipFill>
+          <a:blip r:embed="rId6"/>
           <a:stretch>
             <a:fillRect/>
           </a:stretch>

</xml_diff>